<commit_message>
fixed 1 script in M11.1 slides
</commit_message>
<xml_diff>
--- a/Slides/Module 11.1 Interaction-Level Design.pptx
+++ b/Slides/Module 11.1 Interaction-Level Design.pptx
@@ -3281,7 +3281,7 @@
           <a:p>
             <a:fld id="{7C7E5181-6CF5-45F7-A87A-E0E0B1FD7549}" type="datetimeFigureOut">
               <a:rPr lang="en-US" smtClean="0"/>
-              <a:t>10/7/2026</a:t>
+              <a:t>10/13/2026</a:t>
             </a:fld>
             <a:endParaRPr lang="en-US"/>
           </a:p>
@@ -3993,7 +3993,7 @@
           <a:p>
             <a:r>
               <a:rPr lang="en-US" dirty="0"/>
-              <a:t>Clients of the pulling clock don’t hold on to any references to the clock — so the clock has to hold on to references to its clients. Whenever the time changes, the clock fulfills its obligation to contact all its clients.</a:t>
+              <a:t>Clients of the pushing clock don’t hold on to any references to the clock — so the clock has to hold on to references to its clients. Whenever the time changes, the clock fulfills its obligation to contact all its clients.</a:t>
             </a:r>
           </a:p>
         </p:txBody>
@@ -6585,7 +6585,7 @@
           <a:p>
             <a:fld id="{5D2A64DE-480B-420F-9649-4F8E696E08E0}" type="datetime1">
               <a:rPr lang="en-US" smtClean="0"/>
-              <a:t>10/7/2026</a:t>
+              <a:t>10/13/2026</a:t>
             </a:fld>
             <a:endParaRPr lang="en-US"/>
           </a:p>
@@ -6909,7 +6909,7 @@
           <a:p>
             <a:fld id="{EA476A42-A091-4468-A075-64A31BE59948}" type="datetime1">
               <a:rPr lang="en-US" smtClean="0"/>
-              <a:t>10/7/2026</a:t>
+              <a:t>10/13/2026</a:t>
             </a:fld>
             <a:endParaRPr lang="en-US"/>
           </a:p>
@@ -7107,7 +7107,7 @@
           <a:p>
             <a:fld id="{0D3616D0-8311-4107-9726-6B805E7D05BA}" type="datetime1">
               <a:rPr lang="en-US" smtClean="0"/>
-              <a:t>10/7/2026</a:t>
+              <a:t>10/13/2026</a:t>
             </a:fld>
             <a:endParaRPr lang="en-US"/>
           </a:p>
@@ -7315,7 +7315,7 @@
           <a:p>
             <a:fld id="{3BC2557A-5C88-417A-A763-5AC779462A5F}" type="datetime1">
               <a:rPr lang="en-US" smtClean="0"/>
-              <a:t>10/7/2026</a:t>
+              <a:t>10/13/2026</a:t>
             </a:fld>
             <a:endParaRPr lang="en-US"/>
           </a:p>
@@ -7839,7 +7839,7 @@
           <a:p>
             <a:fld id="{07C7BFD4-467E-4EDE-93EA-052F5B39A4E5}" type="datetime1">
               <a:rPr lang="en-US" smtClean="0"/>
-              <a:t>10/7/2026</a:t>
+              <a:t>10/13/2026</a:t>
             </a:fld>
             <a:endParaRPr lang="en-US"/>
           </a:p>
@@ -8089,7 +8089,7 @@
           <a:p>
             <a:fld id="{07C7BFD4-467E-4EDE-93EA-052F5B39A4E5}" type="datetime1">
               <a:rPr lang="en-US" smtClean="0"/>
-              <a:t>10/7/2026</a:t>
+              <a:t>10/13/2026</a:t>
             </a:fld>
             <a:endParaRPr lang="en-US"/>
           </a:p>
@@ -8277,7 +8277,7 @@
           <a:p>
             <a:fld id="{109E55A0-C911-4F03-82FC-7E5926047D46}" type="datetime1">
               <a:rPr lang="en-US" smtClean="0"/>
-              <a:t>10/7/2026</a:t>
+              <a:t>10/13/2026</a:t>
             </a:fld>
             <a:endParaRPr lang="en-US"/>
           </a:p>
@@ -8590,7 +8590,7 @@
           <a:p>
             <a:fld id="{A533CBE2-D5BE-47AC-ADC2-9CDFC1D0CF90}" type="datetime1">
               <a:rPr lang="en-US" smtClean="0"/>
-              <a:t>10/7/2026</a:t>
+              <a:t>10/13/2026</a:t>
             </a:fld>
             <a:endParaRPr lang="en-US"/>
           </a:p>
@@ -8891,7 +8891,7 @@
           <a:p>
             <a:fld id="{39B7EDB1-CE74-4951-85A2-0B01C2128E28}" type="datetime1">
               <a:rPr lang="en-US" smtClean="0"/>
-              <a:t>10/7/2026</a:t>
+              <a:t>10/13/2026</a:t>
             </a:fld>
             <a:endParaRPr lang="en-US"/>
           </a:p>
@@ -9339,7 +9339,7 @@
           <a:p>
             <a:fld id="{2BC7EB92-A5C2-4807-A9DC-9EDE6CBFB241}" type="datetime1">
               <a:rPr lang="en-US" smtClean="0"/>
-              <a:t>10/7/2026</a:t>
+              <a:t>10/13/2026</a:t>
             </a:fld>
             <a:endParaRPr lang="en-US"/>
           </a:p>
@@ -9452,7 +9452,7 @@
           <a:p>
             <a:fld id="{2B7B7EE0-7771-4CD5-9B2B-3550753A54A1}" type="datetime1">
               <a:rPr lang="en-US" smtClean="0"/>
-              <a:t>10/7/2026</a:t>
+              <a:t>10/13/2026</a:t>
             </a:fld>
             <a:endParaRPr lang="en-US"/>
           </a:p>
@@ -9763,7 +9763,7 @@
           <a:p>
             <a:fld id="{F8B318B3-0E87-4416-A9B8-D891968C2727}" type="datetime1">
               <a:rPr lang="en-US" smtClean="0"/>
-              <a:t>10/7/2026</a:t>
+              <a:t>10/13/2026</a:t>
             </a:fld>
             <a:endParaRPr lang="en-US"/>
           </a:p>
@@ -10004,7 +10004,7 @@
           <a:p>
             <a:fld id="{54D997E8-DDEE-43F1-8D9B-F8A1E11DE488}" type="datetime1">
               <a:rPr lang="en-US" smtClean="0"/>
-              <a:t>10/7/2026</a:t>
+              <a:t>10/13/2026</a:t>
             </a:fld>
             <a:endParaRPr lang="en-US"/>
           </a:p>

</xml_diff>